<commit_message>
Lecture07 prepared for class
</commit_message>
<xml_diff>
--- a/reading/ReadingAssignment_Week_04.pptx
+++ b/reading/ReadingAssignment_Week_04.pptx
@@ -3377,6 +3377,17 @@
           <a:p>
             <a:r>
               <a:rPr lang="en-US" dirty="0"/>
+              <a:t>Section 5.7, Linear Systems with </a:t>
+            </a:r>
+            <a:r>
+              <a:rPr lang="en-US"/>
+              <a:t>Generalized Linear Phase</a:t>
+            </a:r>
+            <a:endParaRPr lang="en-US" dirty="0"/>
+          </a:p>
+          <a:p>
+            <a:r>
+              <a:rPr lang="en-US" dirty="0"/>
               <a:t>Chapter 7, Filter Design Techniques in Oppenheim/Schafer Book.</a:t>
             </a:r>
           </a:p>
@@ -3386,10 +3397,13 @@
               <a:t>Section “Performing Discrete Convolutions” in Chapter 14, Classifying Images with Deep Convolutional Neural Networks in Raschka/Liu/</a:t>
             </a:r>
             <a:r>
-              <a:rPr lang="en-US"/>
-              <a:t>Mirjalili Book.</a:t>
-            </a:r>
-            <a:endParaRPr lang="en-US" dirty="0"/>
+              <a:rPr lang="en-US" dirty="0" err="1"/>
+              <a:t>Mirjalili</a:t>
+            </a:r>
+            <a:r>
+              <a:rPr lang="en-US" dirty="0"/>
+              <a:t> Book.</a:t>
+            </a:r>
           </a:p>
         </p:txBody>
       </p:sp>

</xml_diff>